<commit_message>
updated the readme and the ppt
</commit_message>
<xml_diff>
--- a/presentation/Coffee-Beans-Sales-Analysis-Presentation.pptx
+++ b/presentation/Coffee-Beans-Sales-Analysis-Presentation.pptx
@@ -120,6 +120,11 @@
       </a:defRPr>
     </a:lvl9pPr>
   </p:defaultTextStyle>
+  <p:extLst>
+    <p:ext uri="{EFAFB233-063F-42B5-8137-9DF3F51BA10A}">
+      <p15:sldGuideLst xmlns:p15="http://schemas.microsoft.com/office/powerpoint/2012/main"/>
+    </p:ext>
+  </p:extLst>
 </p:presentation>
 </file>
 
@@ -6475,7 +6480,7 @@
         </p:nvSpPr>
         <p:spPr>
           <a:xfrm>
-            <a:off x="9377930" y="843677"/>
+            <a:off x="9377930" y="882314"/>
             <a:ext cx="2750569" cy="2031325"/>
           </a:xfrm>
           <a:prstGeom prst="rect">

</xml_diff>